<commit_message>
minor update the pptx template
</commit_message>
<xml_diff>
--- a/pptx/TIEV-pre-template.pptx
+++ b/pptx/TIEV-pre-template.pptx
@@ -213,7 +213,7 @@
           <a:p>
             <a:fld id="{6F556B9A-5015-4D8E-B654-F92C2FEC665A}" type="datetimeFigureOut">
               <a:rPr lang="en-US" smtClean="0"/>
-              <a:t>5/8/26</a:t>
+              <a:t>5/11/26</a:t>
             </a:fld>
             <a:endParaRPr lang="en-US"/>
           </a:p>
@@ -572,7 +572,9 @@
               <a:lnSpc>
                 <a:spcPct val="125000"/>
               </a:lnSpc>
-              <a:defRPr sz="6000"/>
+              <a:defRPr sz="6000" baseline="0">
+                <a:latin typeface="Arial" panose="020B0604020202020204" pitchFamily="34" charset="0"/>
+              </a:defRPr>
             </a:lvl1pPr>
           </a:lstStyle>
           <a:p>
@@ -822,7 +824,7 @@
           <a:lstStyle>
             <a:lvl1pPr>
               <a:defRPr sz="4400" b="0" baseline="0">
-                <a:latin typeface="黑体" panose="02010609060101010101" pitchFamily="49" charset="-122"/>
+                <a:latin typeface="Arial Unicode MS" panose="020B0604020202020204" pitchFamily="34" charset="-128"/>
                 <a:ea typeface="黑体" panose="02010609060101010101" pitchFamily="49" charset="-122"/>
               </a:defRPr>
             </a:lvl1pPr>
@@ -847,14 +849,14 @@
         </p:nvSpPr>
         <p:spPr>
           <a:xfrm>
-            <a:off x="609600" y="1383072"/>
+            <a:off x="609600" y="1608434"/>
             <a:ext cx="10972800" cy="4525963"/>
           </a:xfrm>
         </p:spPr>
         <p:txBody>
           <a:bodyPr/>
           <a:lstStyle>
-            <a:lvl1pPr>
+            <a:lvl1pPr algn="just">
               <a:buClr>
                 <a:srgbClr val="2462C6"/>
               </a:buClr>
@@ -863,7 +865,7 @@
                 <a:ea typeface="等线" panose="02010600030101010101" pitchFamily="2" charset="-122"/>
               </a:defRPr>
             </a:lvl1pPr>
-            <a:lvl2pPr>
+            <a:lvl2pPr algn="just">
               <a:buClr>
                 <a:srgbClr val="2462C6"/>
               </a:buClr>
@@ -872,7 +874,7 @@
                 <a:ea typeface="等线" panose="02010600030101010101" pitchFamily="2" charset="-122"/>
               </a:defRPr>
             </a:lvl2pPr>
-            <a:lvl3pPr>
+            <a:lvl3pPr algn="just">
               <a:buClr>
                 <a:srgbClr val="2462C6"/>
               </a:buClr>
@@ -881,7 +883,7 @@
                 <a:ea typeface="等线" panose="02010600030101010101" pitchFamily="2" charset="-122"/>
               </a:defRPr>
             </a:lvl3pPr>
-            <a:lvl4pPr>
+            <a:lvl4pPr algn="just">
               <a:buClr>
                 <a:srgbClr val="2462C6"/>
               </a:buClr>
@@ -890,7 +892,7 @@
                 <a:ea typeface="等线" panose="02010600030101010101" pitchFamily="2" charset="-122"/>
               </a:defRPr>
             </a:lvl4pPr>
-            <a:lvl5pPr>
+            <a:lvl5pPr algn="just">
               <a:buClr>
                 <a:srgbClr val="2462C6"/>
               </a:buClr>
@@ -1170,9 +1172,13 @@
           </a:bodyPr>
           <a:lstStyle>
             <a:lvl1pPr>
-              <a:defRPr sz="4400" b="0" baseline="0">
-                <a:latin typeface="黑体" panose="02010609060101010101" pitchFamily="49" charset="-122"/>
+              <a:defRPr lang="zh-CN" altLang="en-US" sz="4400" b="0" kern="1200" baseline="0" dirty="0">
+                <a:solidFill>
+                  <a:schemeClr val="tx1"/>
+                </a:solidFill>
+                <a:latin typeface="Arial Unicode MS" panose="020B0604020202020204" pitchFamily="34" charset="-128"/>
                 <a:ea typeface="黑体" panose="02010609060101010101" pitchFamily="49" charset="-122"/>
+                <a:cs typeface="+mj-cs"/>
               </a:defRPr>
             </a:lvl1pPr>
           </a:lstStyle>
@@ -1203,7 +1209,7 @@
         <p:txBody>
           <a:bodyPr/>
           <a:lstStyle>
-            <a:lvl1pPr>
+            <a:lvl1pPr algn="just">
               <a:buClr>
                 <a:srgbClr val="2462C6"/>
               </a:buClr>
@@ -1212,7 +1218,7 @@
                 <a:ea typeface="等线" panose="02010600030101010101" pitchFamily="2" charset="-122"/>
               </a:defRPr>
             </a:lvl1pPr>
-            <a:lvl2pPr>
+            <a:lvl2pPr algn="just">
               <a:buClr>
                 <a:srgbClr val="2462C6"/>
               </a:buClr>
@@ -1221,7 +1227,7 @@
                 <a:ea typeface="等线" panose="02010600030101010101" pitchFamily="2" charset="-122"/>
               </a:defRPr>
             </a:lvl2pPr>
-            <a:lvl3pPr>
+            <a:lvl3pPr algn="just">
               <a:buClr>
                 <a:srgbClr val="2462C6"/>
               </a:buClr>
@@ -1230,7 +1236,7 @@
                 <a:ea typeface="等线" panose="02010600030101010101" pitchFamily="2" charset="-122"/>
               </a:defRPr>
             </a:lvl3pPr>
-            <a:lvl4pPr>
+            <a:lvl4pPr algn="just">
               <a:buClr>
                 <a:srgbClr val="2462C6"/>
               </a:buClr>
@@ -1239,7 +1245,7 @@
                 <a:ea typeface="等线" panose="02010600030101010101" pitchFamily="2" charset="-122"/>
               </a:defRPr>
             </a:lvl4pPr>
-            <a:lvl5pPr>
+            <a:lvl5pPr algn="just">
               <a:buClr>
                 <a:srgbClr val="2462C6"/>
               </a:buClr>
@@ -1311,7 +1317,7 @@
         <p:txBody>
           <a:bodyPr/>
           <a:lstStyle>
-            <a:lvl1pPr>
+            <a:lvl1pPr algn="just">
               <a:buClr>
                 <a:srgbClr val="2462C6"/>
               </a:buClr>
@@ -1320,7 +1326,7 @@
                 <a:ea typeface="等线" panose="02010600030101010101" pitchFamily="2" charset="-122"/>
               </a:defRPr>
             </a:lvl1pPr>
-            <a:lvl2pPr>
+            <a:lvl2pPr algn="just">
               <a:buClr>
                 <a:srgbClr val="2462C6"/>
               </a:buClr>
@@ -1329,7 +1335,7 @@
                 <a:ea typeface="等线" panose="02010600030101010101" pitchFamily="2" charset="-122"/>
               </a:defRPr>
             </a:lvl2pPr>
-            <a:lvl3pPr>
+            <a:lvl3pPr algn="just">
               <a:buClr>
                 <a:srgbClr val="2462C6"/>
               </a:buClr>
@@ -1338,7 +1344,7 @@
                 <a:ea typeface="等线" panose="02010600030101010101" pitchFamily="2" charset="-122"/>
               </a:defRPr>
             </a:lvl3pPr>
-            <a:lvl4pPr>
+            <a:lvl4pPr algn="just">
               <a:buClr>
                 <a:srgbClr val="2462C6"/>
               </a:buClr>
@@ -1347,7 +1353,7 @@
                 <a:ea typeface="等线" panose="02010600030101010101" pitchFamily="2" charset="-122"/>
               </a:defRPr>
             </a:lvl4pPr>
-            <a:lvl5pPr>
+            <a:lvl5pPr algn="just">
               <a:buClr>
                 <a:srgbClr val="2462C6"/>
               </a:buClr>
@@ -2146,89 +2152,6 @@
       </p:grpSpPr>
       <p:sp>
         <p:nvSpPr>
-          <p:cNvPr id="3" name="内容占位符 2"/>
-          <p:cNvSpPr>
-            <a:spLocks noGrp="1"/>
-          </p:cNvSpPr>
-          <p:nvPr>
-            <p:ph idx="1"/>
-          </p:nvPr>
-        </p:nvSpPr>
-        <p:spPr>
-          <a:xfrm>
-            <a:off x="852117" y="1373473"/>
-            <a:ext cx="10972800" cy="2621992"/>
-          </a:xfrm>
-        </p:spPr>
-        <p:txBody>
-          <a:bodyPr>
-            <a:normAutofit/>
-          </a:bodyPr>
-          <a:lstStyle>
-            <a:lvl1pPr marL="11113" indent="-11113" algn="ctr">
-              <a:buClr>
-                <a:srgbClr val="00B0F0"/>
-              </a:buClr>
-              <a:buNone/>
-              <a:tabLst/>
-              <a:defRPr sz="5400" baseline="0">
-                <a:latin typeface="DengXian" panose="02010600030101010101" pitchFamily="2" charset="-122"/>
-                <a:ea typeface="DengXian" panose="02010600030101010101" pitchFamily="2" charset="-122"/>
-              </a:defRPr>
-            </a:lvl1pPr>
-            <a:lvl2pPr>
-              <a:buClr>
-                <a:srgbClr val="00B0F0"/>
-              </a:buClr>
-              <a:defRPr baseline="0">
-                <a:latin typeface="Times New Roman" panose="02020603050405020304" pitchFamily="18" charset="0"/>
-                <a:ea typeface="等线" panose="02010600030101010101" pitchFamily="2" charset="-122"/>
-              </a:defRPr>
-            </a:lvl2pPr>
-            <a:lvl3pPr>
-              <a:buClr>
-                <a:srgbClr val="00B0F0"/>
-              </a:buClr>
-              <a:defRPr baseline="0">
-                <a:latin typeface="Times New Roman" panose="02020603050405020304" pitchFamily="18" charset="0"/>
-                <a:ea typeface="等线" panose="02010600030101010101" pitchFamily="2" charset="-122"/>
-              </a:defRPr>
-            </a:lvl3pPr>
-            <a:lvl4pPr>
-              <a:buClr>
-                <a:srgbClr val="00B0F0"/>
-              </a:buClr>
-              <a:defRPr baseline="0">
-                <a:latin typeface="Times New Roman" panose="02020603050405020304" pitchFamily="18" charset="0"/>
-                <a:ea typeface="等线" panose="02010600030101010101" pitchFamily="2" charset="-122"/>
-              </a:defRPr>
-            </a:lvl4pPr>
-            <a:lvl5pPr>
-              <a:buClr>
-                <a:srgbClr val="00B0F0"/>
-              </a:buClr>
-              <a:defRPr baseline="0">
-                <a:latin typeface="Times New Roman" panose="02020603050405020304" pitchFamily="18" charset="0"/>
-                <a:ea typeface="等线" panose="02010600030101010101" pitchFamily="2" charset="-122"/>
-              </a:defRPr>
-            </a:lvl5pPr>
-          </a:lstStyle>
-          <a:p>
-            <a:pPr lvl="0"/>
-            <a:endParaRPr lang="en-US" altLang="zh-CN" dirty="0"/>
-          </a:p>
-          <a:p>
-            <a:pPr lvl="0"/>
-            <a:r>
-              <a:rPr lang="zh-CN" altLang="en-US" dirty="0"/>
-              <a:t>敬请批评指正！</a:t>
-            </a:r>
-            <a:endParaRPr lang="en-US" altLang="zh-CN" dirty="0"/>
-          </a:p>
-        </p:txBody>
-      </p:sp>
-      <p:sp>
-        <p:nvSpPr>
           <p:cNvPr id="8" name="矩形 7"/>
           <p:cNvSpPr/>
           <p:nvPr userDrawn="1"/>
@@ -2281,63 +2204,6 @@
       </p:sp>
       <p:sp>
         <p:nvSpPr>
-          <p:cNvPr id="15" name="文本框 14">
-            <a:extLst>
-              <a:ext uri="{FF2B5EF4-FFF2-40B4-BE49-F238E27FC236}">
-                <a16:creationId xmlns:a16="http://schemas.microsoft.com/office/drawing/2014/main" id="{31DF8603-6F20-E319-2A23-91AD2D483DA7}"/>
-              </a:ext>
-            </a:extLst>
-          </p:cNvPr>
-          <p:cNvSpPr txBox="1"/>
-          <p:nvPr userDrawn="1"/>
-        </p:nvSpPr>
-        <p:spPr>
-          <a:xfrm>
-            <a:off x="3044952" y="3995465"/>
-            <a:ext cx="6102096" cy="954107"/>
-          </a:xfrm>
-          <a:prstGeom prst="rect">
-            <a:avLst/>
-          </a:prstGeom>
-          <a:noFill/>
-        </p:spPr>
-        <p:txBody>
-          <a:bodyPr wrap="square">
-            <a:spAutoFit/>
-          </a:bodyPr>
-          <a:lstStyle/>
-          <a:p>
-            <a:pPr lvl="0" algn="ctr"/>
-            <a:r>
-              <a:rPr lang="zh-CN" altLang="en-US" sz="2800" dirty="0">
-                <a:latin typeface="DengXian" panose="02010600030101010101" pitchFamily="2" charset="-122"/>
-                <a:ea typeface="DengXian" panose="02010600030101010101" pitchFamily="2" charset="-122"/>
-              </a:rPr>
-              <a:t>姓名</a:t>
-            </a:r>
-            <a:endParaRPr lang="en-US" altLang="zh-CN" sz="2800" dirty="0">
-              <a:latin typeface="DengXian" panose="02010600030101010101" pitchFamily="2" charset="-122"/>
-              <a:ea typeface="DengXian" panose="02010600030101010101" pitchFamily="2" charset="-122"/>
-            </a:endParaRPr>
-          </a:p>
-          <a:p>
-            <a:pPr lvl="0" algn="ctr"/>
-            <a:r>
-              <a:rPr lang="zh-CN" altLang="en-US" sz="2800" dirty="0">
-                <a:latin typeface="DengXian" panose="02010600030101010101" pitchFamily="2" charset="-122"/>
-                <a:ea typeface="DengXian" panose="02010600030101010101" pitchFamily="2" charset="-122"/>
-              </a:rPr>
-              <a:t>邮箱</a:t>
-            </a:r>
-            <a:endParaRPr lang="en-US" altLang="zh-CN" sz="2800" dirty="0">
-              <a:latin typeface="DengXian" panose="02010600030101010101" pitchFamily="2" charset="-122"/>
-              <a:ea typeface="DengXian" panose="02010600030101010101" pitchFamily="2" charset="-122"/>
-            </a:endParaRPr>
-          </a:p>
-        </p:txBody>
-      </p:sp>
-      <p:sp>
-        <p:nvSpPr>
           <p:cNvPr id="17" name="页脚占位符 3">
             <a:extLst>
               <a:ext uri="{FF2B5EF4-FFF2-40B4-BE49-F238E27FC236}">
@@ -2452,6 +2318,134 @@
           </a:prstGeom>
         </p:spPr>
       </p:pic>
+      <p:sp>
+        <p:nvSpPr>
+          <p:cNvPr id="5" name="内容占位符 4">
+            <a:extLst>
+              <a:ext uri="{FF2B5EF4-FFF2-40B4-BE49-F238E27FC236}">
+                <a16:creationId xmlns:a16="http://schemas.microsoft.com/office/drawing/2014/main" id="{CBB81383-DF0C-9428-43D3-482468EEB381}"/>
+              </a:ext>
+            </a:extLst>
+          </p:cNvPr>
+          <p:cNvSpPr>
+            <a:spLocks noGrp="1"/>
+          </p:cNvSpPr>
+          <p:nvPr>
+            <p:ph sz="quarter" idx="12" hasCustomPrompt="1"/>
+          </p:nvPr>
+        </p:nvSpPr>
+        <p:spPr>
+          <a:xfrm>
+            <a:off x="3323431" y="4005064"/>
+            <a:ext cx="5545138" cy="1008063"/>
+          </a:xfrm>
+        </p:spPr>
+        <p:txBody>
+          <a:bodyPr>
+            <a:noAutofit/>
+          </a:bodyPr>
+          <a:lstStyle>
+            <a:lvl1pPr>
+              <a:buNone/>
+              <a:defRPr lang="en-US" altLang="zh-CN" sz="2800" dirty="0"/>
+            </a:lvl1pPr>
+          </a:lstStyle>
+          <a:p>
+            <a:pPr lvl="0" algn="ctr"/>
+            <a:r>
+              <a:rPr lang="zh-CN" altLang="en-US" sz="3200" dirty="0">
+                <a:latin typeface="DengXian" panose="02010600030101010101" pitchFamily="2" charset="-122"/>
+                <a:ea typeface="DengXian" panose="02010600030101010101" pitchFamily="2" charset="-122"/>
+              </a:rPr>
+              <a:t>姓名</a:t>
+            </a:r>
+            <a:endParaRPr lang="en-US" altLang="zh-CN" sz="3200" dirty="0">
+              <a:latin typeface="DengXian" panose="02010600030101010101" pitchFamily="2" charset="-122"/>
+              <a:ea typeface="DengXian" panose="02010600030101010101" pitchFamily="2" charset="-122"/>
+            </a:endParaRPr>
+          </a:p>
+          <a:p>
+            <a:pPr lvl="0" algn="ctr"/>
+            <a:r>
+              <a:rPr lang="zh-CN" altLang="en-US" sz="3200" dirty="0">
+                <a:latin typeface="DengXian" panose="02010600030101010101" pitchFamily="2" charset="-122"/>
+                <a:ea typeface="DengXian" panose="02010600030101010101" pitchFamily="2" charset="-122"/>
+              </a:rPr>
+              <a:t>邮箱</a:t>
+            </a:r>
+            <a:endParaRPr lang="en-US" altLang="zh-CN" sz="3200" dirty="0">
+              <a:latin typeface="DengXian" panose="02010600030101010101" pitchFamily="2" charset="-122"/>
+              <a:ea typeface="DengXian" panose="02010600030101010101" pitchFamily="2" charset="-122"/>
+            </a:endParaRPr>
+          </a:p>
+        </p:txBody>
+      </p:sp>
+      <p:sp>
+        <p:nvSpPr>
+          <p:cNvPr id="10" name="内容占位符 9">
+            <a:extLst>
+              <a:ext uri="{FF2B5EF4-FFF2-40B4-BE49-F238E27FC236}">
+                <a16:creationId xmlns:a16="http://schemas.microsoft.com/office/drawing/2014/main" id="{38170701-EAAC-CB29-5AD7-5F3BE97789C7}"/>
+              </a:ext>
+            </a:extLst>
+          </p:cNvPr>
+          <p:cNvSpPr>
+            <a:spLocks noGrp="1"/>
+          </p:cNvSpPr>
+          <p:nvPr>
+            <p:ph sz="quarter" idx="13" hasCustomPrompt="1"/>
+          </p:nvPr>
+        </p:nvSpPr>
+        <p:spPr>
+          <a:xfrm>
+            <a:off x="1631950" y="1916832"/>
+            <a:ext cx="8999537" cy="2015877"/>
+          </a:xfrm>
+        </p:spPr>
+        <p:txBody>
+          <a:bodyPr/>
+          <a:lstStyle>
+            <a:lvl1pPr algn="ctr">
+              <a:buNone/>
+              <a:defRPr sz="4400" b="1" i="0" baseline="0">
+                <a:latin typeface="Arial Unicode MS" panose="020B0604020202020204" pitchFamily="34" charset="-128"/>
+                <a:ea typeface="黑体" panose="02010609060101010101" pitchFamily="49" charset="-122"/>
+              </a:defRPr>
+            </a:lvl1pPr>
+            <a:lvl2pPr>
+              <a:buNone/>
+              <a:defRPr/>
+            </a:lvl2pPr>
+            <a:lvl3pPr>
+              <a:buNone/>
+              <a:defRPr/>
+            </a:lvl3pPr>
+            <a:lvl4pPr>
+              <a:buNone/>
+              <a:defRPr/>
+            </a:lvl4pPr>
+            <a:lvl5pPr>
+              <a:buNone/>
+              <a:defRPr/>
+            </a:lvl5pPr>
+          </a:lstStyle>
+          <a:p>
+            <a:pPr lvl="0"/>
+            <a:r>
+              <a:rPr kumimoji="1" lang="zh-CN" altLang="en-US" dirty="0"/>
+              <a:t>谢谢！</a:t>
+            </a:r>
+            <a:endParaRPr kumimoji="1" lang="en-US" altLang="zh-CN" dirty="0"/>
+          </a:p>
+          <a:p>
+            <a:pPr lvl="0"/>
+            <a:r>
+              <a:rPr kumimoji="1" lang="zh-CN" altLang="en-US" dirty="0"/>
+              <a:t>敬请批评指正！</a:t>
+            </a:r>
+          </a:p>
+        </p:txBody>
+      </p:sp>
     </p:spTree>
     <p:extLst>
       <p:ext uri="{BB962C8B-B14F-4D97-AF65-F5344CB8AC3E}">
@@ -2685,7 +2679,7 @@
           <a:solidFill>
             <a:schemeClr val="tx1"/>
           </a:solidFill>
-          <a:latin typeface="Times New Roman" panose="02020603050405020304" pitchFamily="18" charset="0"/>
+          <a:latin typeface="Arial Unicode MS" panose="020B0604020202020204" pitchFamily="34" charset="-128"/>
           <a:ea typeface="黑体" panose="02010609060101010101" pitchFamily="49" charset="-122"/>
           <a:cs typeface="+mj-cs"/>
         </a:defRPr>
@@ -3075,7 +3069,7 @@
           <a:bodyPr/>
           <a:lstStyle/>
           <a:p>
-            <a:endParaRPr kumimoji="1" lang="zh-CN" altLang="en-US"/>
+            <a:endParaRPr kumimoji="1" lang="zh-CN" altLang="en-US" dirty="0"/>
           </a:p>
         </p:txBody>
       </p:sp>
@@ -3095,7 +3089,12 @@
             <p:ph idx="1"/>
           </p:nvPr>
         </p:nvSpPr>
-        <p:spPr/>
+        <p:spPr>
+          <a:xfrm>
+            <a:off x="609600" y="1608483"/>
+            <a:ext cx="10972800" cy="4525963"/>
+          </a:xfrm>
+        </p:spPr>
         <p:txBody>
           <a:bodyPr/>
           <a:lstStyle/>
@@ -3211,10 +3210,14 @@
         </p:nvSpPr>
         <p:spPr/>
         <p:txBody>
-          <a:bodyPr/>
+          <a:bodyPr>
+            <a:normAutofit/>
+          </a:bodyPr>
           <a:lstStyle/>
           <a:p>
-            <a:endParaRPr lang="zh-CN" altLang="en-US"/>
+            <a:endParaRPr kumimoji="1" lang="zh-CN" altLang="en-US" dirty="0">
+              <a:latin typeface="Arial Unicode MS" panose="020B0604020202020204" pitchFamily="34" charset="-128"/>
+            </a:endParaRPr>
           </a:p>
         </p:txBody>
       </p:sp>
@@ -3580,31 +3583,6 @@
       </p:grpSpPr>
       <p:sp>
         <p:nvSpPr>
-          <p:cNvPr id="2" name="内容占位符 1">
-            <a:extLst>
-              <a:ext uri="{FF2B5EF4-FFF2-40B4-BE49-F238E27FC236}">
-                <a16:creationId xmlns:a16="http://schemas.microsoft.com/office/drawing/2014/main" id="{983B3910-9CA0-8B88-EF38-8041FB55A62B}"/>
-              </a:ext>
-            </a:extLst>
-          </p:cNvPr>
-          <p:cNvSpPr>
-            <a:spLocks noGrp="1"/>
-          </p:cNvSpPr>
-          <p:nvPr>
-            <p:ph idx="1"/>
-          </p:nvPr>
-        </p:nvSpPr>
-        <p:spPr/>
-        <p:txBody>
-          <a:bodyPr/>
-          <a:lstStyle/>
-          <a:p>
-            <a:endParaRPr kumimoji="1" lang="zh-CN" altLang="en-US"/>
-          </a:p>
-        </p:txBody>
-      </p:sp>
-      <p:sp>
-        <p:nvSpPr>
           <p:cNvPr id="3" name="页脚占位符 2">
             <a:extLst>
               <a:ext uri="{FF2B5EF4-FFF2-40B4-BE49-F238E27FC236}">
@@ -3632,6 +3610,56 @@
               <a:latin typeface="DengXian" panose="02010600030101010101" pitchFamily="2" charset="-122"/>
               <a:ea typeface="DengXian" panose="02010600030101010101" pitchFamily="2" charset="-122"/>
             </a:endParaRPr>
+          </a:p>
+        </p:txBody>
+      </p:sp>
+      <p:sp>
+        <p:nvSpPr>
+          <p:cNvPr id="5" name="内容占位符 4">
+            <a:extLst>
+              <a:ext uri="{FF2B5EF4-FFF2-40B4-BE49-F238E27FC236}">
+                <a16:creationId xmlns:a16="http://schemas.microsoft.com/office/drawing/2014/main" id="{7A5DE555-BAB6-2B62-A7CE-6E164EC6A246}"/>
+              </a:ext>
+            </a:extLst>
+          </p:cNvPr>
+          <p:cNvSpPr>
+            <a:spLocks noGrp="1"/>
+          </p:cNvSpPr>
+          <p:nvPr>
+            <p:ph sz="quarter" idx="12"/>
+          </p:nvPr>
+        </p:nvSpPr>
+        <p:spPr/>
+        <p:txBody>
+          <a:bodyPr/>
+          <a:lstStyle/>
+          <a:p>
+            <a:endParaRPr lang="zh-CN" altLang="en-US" dirty="0"/>
+          </a:p>
+        </p:txBody>
+      </p:sp>
+      <p:sp>
+        <p:nvSpPr>
+          <p:cNvPr id="6" name="内容占位符 5">
+            <a:extLst>
+              <a:ext uri="{FF2B5EF4-FFF2-40B4-BE49-F238E27FC236}">
+                <a16:creationId xmlns:a16="http://schemas.microsoft.com/office/drawing/2014/main" id="{24917FAD-FCB1-2473-C81C-F05CF35526C3}"/>
+              </a:ext>
+            </a:extLst>
+          </p:cNvPr>
+          <p:cNvSpPr>
+            <a:spLocks noGrp="1"/>
+          </p:cNvSpPr>
+          <p:nvPr>
+            <p:ph sz="quarter" idx="13"/>
+          </p:nvPr>
+        </p:nvSpPr>
+        <p:spPr/>
+        <p:txBody>
+          <a:bodyPr/>
+          <a:lstStyle/>
+          <a:p>
+            <a:endParaRPr lang="zh-CN" altLang="en-US" dirty="0"/>
           </a:p>
         </p:txBody>
       </p:sp>

</xml_diff>